<commit_message>
primera sesión lab 2
</commit_message>
<xml_diff>
--- a/LabBook_20.pptx
+++ b/LabBook_20.pptx
@@ -9220,6 +9220,45 @@
             </a:endParaRPr>
           </a:p>
           <a:p>
+            <a:pPr marL="800100" lvl="1" indent="-342900" algn="just">
+              <a:buFont typeface="Arial" panose="020B0604020202020204" pitchFamily="34" charset="0"/>
+              <a:buChar char="•"/>
+            </a:pPr>
+            <a:r>
+              <a:rPr lang="en-US" kern="0" dirty="0">
+                <a:solidFill>
+                  <a:sysClr val="windowText" lastClr="000000"/>
+                </a:solidFill>
+                <a:sym typeface="Wingdings" pitchFamily="2" charset="2"/>
+              </a:rPr>
+              <a:t>Terminal + ‘</a:t>
+            </a:r>
+            <a:r>
+              <a:rPr lang="en-US" kern="0" dirty="0" err="1">
+                <a:solidFill>
+                  <a:sysClr val="windowText" lastClr="000000"/>
+                </a:solidFill>
+                <a:sym typeface="Wingdings" pitchFamily="2" charset="2"/>
+              </a:rPr>
+              <a:t>uv</a:t>
+            </a:r>
+            <a:r>
+              <a:rPr lang="en-US" kern="0">
+                <a:solidFill>
+                  <a:sysClr val="windowText" lastClr="000000"/>
+                </a:solidFill>
+                <a:sym typeface="Wingdings" pitchFamily="2" charset="2"/>
+              </a:rPr>
+              <a:t> sync’</a:t>
+            </a:r>
+            <a:endParaRPr lang="en-US" kern="0" dirty="0">
+              <a:solidFill>
+                <a:sysClr val="windowText" lastClr="000000"/>
+              </a:solidFill>
+              <a:sym typeface="Wingdings" pitchFamily="2" charset="2"/>
+            </a:endParaRPr>
+          </a:p>
+          <a:p>
             <a:pPr marL="342900" indent="-342900" algn="just">
               <a:buFont typeface="Arial" panose="020B0604020202020204" pitchFamily="34" charset="0"/>
               <a:buChar char="•"/>
@@ -12970,8 +13009,8 @@
           </p:sp>
         </mc:Fallback>
       </mc:AlternateContent>
-      <mc:AlternateContent xmlns:mc="http://schemas.openxmlformats.org/markup-compatibility/2006">
-        <mc:Choice xmlns:a14="http://schemas.microsoft.com/office/drawing/2010/main" Requires="a14">
+      <mc:AlternateContent xmlns:mc="http://schemas.openxmlformats.org/markup-compatibility/2006" xmlns:a14="http://schemas.microsoft.com/office/drawing/2010/main">
+        <mc:Choice Requires="a14">
           <p:sp>
             <p:nvSpPr>
               <p:cNvPr id="10" name="CuadroTexto 9">
@@ -13057,7 +13096,7 @@
             </p:txBody>
           </p:sp>
         </mc:Choice>
-        <mc:Fallback>
+        <mc:Fallback xmlns="">
           <p:sp>
             <p:nvSpPr>
               <p:cNvPr id="10" name="CuadroTexto 9">
@@ -13428,8 +13467,8 @@
           </a:p>
         </p:txBody>
       </p:sp>
-      <mc:AlternateContent xmlns:mc="http://schemas.openxmlformats.org/markup-compatibility/2006">
-        <mc:Choice xmlns:a14="http://schemas.microsoft.com/office/drawing/2010/main" Requires="a14">
+      <mc:AlternateContent xmlns:mc="http://schemas.openxmlformats.org/markup-compatibility/2006" xmlns:a14="http://schemas.microsoft.com/office/drawing/2010/main">
+        <mc:Choice Requires="a14">
           <p:sp>
             <p:nvSpPr>
               <p:cNvPr id="4" name="Marcador de texto 2">
@@ -13663,7 +13702,7 @@
             </p:txBody>
           </p:sp>
         </mc:Choice>
-        <mc:Fallback>
+        <mc:Fallback xmlns="">
           <p:sp>
             <p:nvSpPr>
               <p:cNvPr id="4" name="Marcador de texto 2">

</xml_diff>